<commit_message>
Regenerate slides without logo; neutral disclaimer
Co-Authored-By: Claude Opus 5.5 <noreply@anthropic.com>
Claude-Session: https://claude.ai/code/session_0114iFt1PAdDoDHFkZMRKzse
</commit_message>
<xml_diff>
--- a/case/05-initial-output/INITIAL-003.pptx
+++ b/case/05-initial-output/INITIAL-003.pptx
@@ -149,42 +149,6 @@
           </a:p>
         </p:txBody>
       </p:sp>
-      <p:pic>
-        <p:nvPicPr>
-          <p:cNvPr id="5" name="Picture 4" descr="A black background with white text&#10;&#10;Description automatically generated">
-            <a:extLst>
-              <a:ext uri="{FF2B5EF4-FFF2-40B4-BE49-F238E27FC236}">
-                <a16:creationId xmlns:a16="http://schemas.microsoft.com/office/drawing/2014/main" id="{31E1A3F8-330C-CA87-F88F-8DEE4648AB86}"/>
-              </a:ext>
-            </a:extLst>
-          </p:cNvPr>
-          <p:cNvPicPr>
-            <a:picLocks noChangeAspect="1"/>
-          </p:cNvPicPr>
-          <p:nvPr userDrawn="1"/>
-        </p:nvPicPr>
-        <p:blipFill>
-          <a:blip r:embed="rId2">
-            <a:extLst>
-              <a:ext uri="{28A0092B-C50C-407E-A947-70E740481C1C}">
-                <a14:useLocalDpi xmlns:a14="http://schemas.microsoft.com/office/drawing/2010/main" val="0"/>
-              </a:ext>
-            </a:extLst>
-          </a:blip>
-          <a:stretch>
-            <a:fillRect/>
-          </a:stretch>
-        </p:blipFill>
-        <p:spPr>
-          <a:xfrm>
-            <a:off x="144321" y="190220"/>
-            <a:ext cx="2541467" cy="1175211"/>
-          </a:xfrm>
-          <a:prstGeom prst="rect">
-            <a:avLst/>
-          </a:prstGeom>
-        </p:spPr>
-      </p:pic>
       <p:sp>
         <p:nvSpPr>
           <p:cNvPr id="9" name="Text Placeholder 24">
@@ -665,42 +629,6 @@
           </a:p>
         </p:txBody>
       </p:sp>
-      <p:pic>
-        <p:nvPicPr>
-          <p:cNvPr id="3" name="Picture 2">
-            <a:extLst>
-              <a:ext uri="{FF2B5EF4-FFF2-40B4-BE49-F238E27FC236}">
-                <a16:creationId xmlns:a16="http://schemas.microsoft.com/office/drawing/2014/main" id="{4B46CD71-09A2-2F9E-31DB-C6E2844B4ED8}"/>
-              </a:ext>
-            </a:extLst>
-          </p:cNvPr>
-          <p:cNvPicPr>
-            <a:picLocks noChangeAspect="1"/>
-          </p:cNvPicPr>
-          <p:nvPr userDrawn="1"/>
-        </p:nvPicPr>
-        <p:blipFill>
-          <a:blip r:embed="rId2" cstate="hqprint">
-            <a:extLst>
-              <a:ext uri="{28A0092B-C50C-407E-A947-70E740481C1C}">
-                <a14:useLocalDpi xmlns:a14="http://schemas.microsoft.com/office/drawing/2010/main"/>
-              </a:ext>
-            </a:extLst>
-          </a:blip>
-          <a:stretch>
-            <a:fillRect/>
-          </a:stretch>
-        </p:blipFill>
-        <p:spPr>
-          <a:xfrm>
-            <a:off x="11428461" y="6231295"/>
-            <a:ext cx="523540" cy="375793"/>
-          </a:xfrm>
-          <a:prstGeom prst="rect">
-            <a:avLst/>
-          </a:prstGeom>
-        </p:spPr>
-      </p:pic>
       <p:sp>
         <p:nvSpPr>
           <p:cNvPr id="2" name="Slide Number Placeholder 8">
@@ -1390,42 +1318,6 @@
           </a:p>
         </p:txBody>
       </p:sp>
-      <p:pic>
-        <p:nvPicPr>
-          <p:cNvPr id="9" name="Picture 8">
-            <a:extLst>
-              <a:ext uri="{FF2B5EF4-FFF2-40B4-BE49-F238E27FC236}">
-                <a16:creationId xmlns:a16="http://schemas.microsoft.com/office/drawing/2014/main" id="{FDD69B32-55CC-7E31-2C75-3650BC1CD6B5}"/>
-              </a:ext>
-            </a:extLst>
-          </p:cNvPr>
-          <p:cNvPicPr>
-            <a:picLocks noChangeAspect="1"/>
-          </p:cNvPicPr>
-          <p:nvPr userDrawn="1"/>
-        </p:nvPicPr>
-        <p:blipFill>
-          <a:blip r:embed="rId2" cstate="hqprint">
-            <a:extLst>
-              <a:ext uri="{28A0092B-C50C-407E-A947-70E740481C1C}">
-                <a14:useLocalDpi xmlns:a14="http://schemas.microsoft.com/office/drawing/2010/main"/>
-              </a:ext>
-            </a:extLst>
-          </a:blip>
-          <a:stretch>
-            <a:fillRect/>
-          </a:stretch>
-        </p:blipFill>
-        <p:spPr>
-          <a:xfrm>
-            <a:off x="11428461" y="6231295"/>
-            <a:ext cx="523540" cy="375793"/>
-          </a:xfrm>
-          <a:prstGeom prst="rect">
-            <a:avLst/>
-          </a:prstGeom>
-        </p:spPr>
-      </p:pic>
     </p:spTree>
     <p:extLst>
       <p:ext uri="{BB962C8B-B14F-4D97-AF65-F5344CB8AC3E}">
@@ -3568,7 +3460,7 @@
                 </a:solidFill>
                 <a:latin typeface="Open Sans" panose="020B0606030504020204" pitchFamily="34" charset="0"/>
               </a:rPr>
-              <a:t>Sources: document ID and exact locator. Fictional training case; not A*STAR policy or Singapore procurement law.</a:t>
+              <a:t>Sources: document ID and exact locator. Fictional training case; not organisational policy or Singapore procurement law.</a:t>
             </a:r>
           </a:p>
         </p:txBody>
@@ -5265,7 +5157,7 @@
                 </a:solidFill>
                 <a:latin typeface="Open Sans" panose="020B0606030504020204" pitchFamily="34" charset="0"/>
               </a:rPr>
-              <a:t>Sources: document ID and exact locator. Fictional training case; not A*STAR policy or Singapore procurement law.</a:t>
+              <a:t>Sources: document ID and exact locator. Fictional training case; not organisational policy or Singapore procurement law.</a:t>
             </a:r>
           </a:p>
         </p:txBody>
@@ -6141,7 +6033,7 @@
                 </a:solidFill>
                 <a:latin typeface="Open Sans" panose="020B0606030504020204" pitchFamily="34" charset="0"/>
               </a:rPr>
-              <a:t>Sources: document ID and exact locator. Fictional training case; not A*STAR policy or Singapore procurement law.</a:t>
+              <a:t>Sources: document ID and exact locator. Fictional training case; not organisational policy or Singapore procurement law.</a:t>
             </a:r>
           </a:p>
         </p:txBody>
@@ -6306,7 +6198,7 @@
                 </a:solidFill>
                 <a:latin typeface="Open Sans" panose="020B0606030504020204" pitchFamily="34" charset="0"/>
               </a:rPr>
-              <a:t>Sources: document ID and exact locator. Fictional training case; not A*STAR policy or Singapore procurement law.</a:t>
+              <a:t>Sources: document ID and exact locator. Fictional training case; not organisational policy or Singapore procurement law.</a:t>
             </a:r>
           </a:p>
         </p:txBody>
@@ -7182,7 +7074,7 @@
                 </a:solidFill>
                 <a:latin typeface="Open Sans" panose="020B0606030504020204" pitchFamily="34" charset="0"/>
               </a:rPr>
-              <a:t>Sources: RFQ-002 M1-M7; NST-005 service term; EMAIL-002 service clarification thread; EVAL-001 summary scores; EVAL-002 proposal comparison. Fictional training case; not A*STAR policy or Singapore procurement law.</a:t>
+              <a:t>Sources: RFQ-002 M1-M7; NST-005 service term; EMAIL-002 service clarification thread; EVAL-001 summary scores; EVAL-002 proposal comparison. Fictional training case; not organisational policy or Singapore procurement law.</a:t>
             </a:r>
           </a:p>
         </p:txBody>
@@ -8879,7 +8771,7 @@
                 </a:solidFill>
                 <a:latin typeface="Open Sans" panose="020B0606030504020204" pitchFamily="34" charset="0"/>
               </a:rPr>
-              <a:t>Sources: RFQ-002 M1-M7; NST-005 service term; EMAIL-002 service clarification thread; EVAL-001 summary scores; EVAL-002 proposal comparison. Fictional training case; not A*STAR policy or Singapore procurement law.</a:t>
+              <a:t>Sources: RFQ-002 M1-M7; NST-005 service term; EMAIL-002 service clarification thread; EVAL-001 summary scores; EVAL-002 proposal comparison. Fictional training case; not organisational policy or Singapore procurement law.</a:t>
             </a:r>
           </a:p>
         </p:txBody>
@@ -10576,7 +10468,7 @@
                 </a:solidFill>
                 <a:latin typeface="Open Sans" panose="020B0606030504020204" pitchFamily="34" charset="0"/>
               </a:rPr>
-              <a:t>Sources: RFQ-002 M1-M7; NST-005 service term; EMAIL-002 service clarification thread; EVAL-001 summary scores; EVAL-002 proposal comparison. Fictional training case; not A*STAR policy or Singapore procurement law.</a:t>
+              <a:t>Sources: RFQ-002 M1-M7; NST-005 service term; EMAIL-002 service clarification thread; EVAL-001 summary scores; EVAL-002 proposal comparison. Fictional training case; not organisational policy or Singapore procurement law.</a:t>
             </a:r>
           </a:p>
         </p:txBody>

</xml_diff>